<commit_message>
numerous agent lab updates
</commit_message>
<xml_diff>
--- a/lab-3-agent-builder-custom-mode/v4-wireframes/website-v4-wireframes.pptx
+++ b/lab-3-agent-builder-custom-mode/v4-wireframes/website-v4-wireframes.pptx
@@ -3711,10 +3711,215 @@
       </p:pic>
       <p:sp>
         <p:nvSpPr>
-          <p:cNvPr id="13" name="Rounded Rectangular Callout 12">
-            <a:extLst>
-              <a:ext uri="{FF2B5EF4-FFF2-40B4-BE49-F238E27FC236}">
-                <a16:creationId xmlns:a16="http://schemas.microsoft.com/office/drawing/2014/main" id="{D76ED2D3-42A2-0A69-18B0-48C2159C55E0}"/>
+          <p:cNvPr id="14" name="TextBox 13">
+            <a:extLst>
+              <a:ext uri="{FF2B5EF4-FFF2-40B4-BE49-F238E27FC236}">
+                <a16:creationId xmlns:a16="http://schemas.microsoft.com/office/drawing/2014/main" id="{2BE66C0E-48CC-FF30-51E8-CB7A9ABDC741}"/>
+              </a:ext>
+            </a:extLst>
+          </p:cNvPr>
+          <p:cNvSpPr txBox="1"/>
+          <p:nvPr/>
+        </p:nvSpPr>
+        <p:spPr>
+          <a:xfrm>
+            <a:off x="705079" y="2750470"/>
+            <a:ext cx="4120309" cy="646331"/>
+          </a:xfrm>
+          <a:prstGeom prst="rect">
+            <a:avLst/>
+          </a:prstGeom>
+          <a:noFill/>
+        </p:spPr>
+        <p:txBody>
+          <a:bodyPr wrap="square" rtlCol="0">
+            <a:spAutoFit/>
+          </a:bodyPr>
+          <a:lstStyle/>
+          <a:p>
+            <a:r>
+              <a:rPr lang="en-US" dirty="0"/>
+              <a:t>Agent’s 1</a:t>
+            </a:r>
+            <a:r>
+              <a:rPr lang="en-US" baseline="30000" dirty="0"/>
+              <a:t>st</a:t>
+            </a:r>
+            <a:r>
+              <a:rPr lang="en-US" dirty="0"/>
+              <a:t> response in natural language</a:t>
+            </a:r>
+          </a:p>
+          <a:p>
+            <a:r>
+              <a:rPr lang="en-US" dirty="0"/>
+              <a:t>plus charts and graphs</a:t>
+            </a:r>
+          </a:p>
+        </p:txBody>
+      </p:sp>
+      <p:sp>
+        <p:nvSpPr>
+          <p:cNvPr id="16" name="TextBox 15">
+            <a:extLst>
+              <a:ext uri="{FF2B5EF4-FFF2-40B4-BE49-F238E27FC236}">
+                <a16:creationId xmlns:a16="http://schemas.microsoft.com/office/drawing/2014/main" id="{5F72A68A-E3D1-3878-9B1B-070098E84CF0}"/>
+              </a:ext>
+            </a:extLst>
+          </p:cNvPr>
+          <p:cNvSpPr txBox="1"/>
+          <p:nvPr/>
+        </p:nvSpPr>
+        <p:spPr>
+          <a:xfrm>
+            <a:off x="1608462" y="5023689"/>
+            <a:ext cx="4120309" cy="646331"/>
+          </a:xfrm>
+          <a:prstGeom prst="rect">
+            <a:avLst/>
+          </a:prstGeom>
+          <a:noFill/>
+        </p:spPr>
+        <p:txBody>
+          <a:bodyPr wrap="square" rtlCol="0">
+            <a:spAutoFit/>
+          </a:bodyPr>
+          <a:lstStyle/>
+          <a:p>
+            <a:r>
+              <a:rPr lang="en-US" dirty="0"/>
+              <a:t>Please wait while the agent processes its response…</a:t>
+            </a:r>
+          </a:p>
+        </p:txBody>
+      </p:sp>
+      <p:pic>
+        <p:nvPicPr>
+          <p:cNvPr id="1026" name="Picture 2" descr="Please Wait Notepad Icons - Free SVG &amp; PNG Please Wait ...">
+            <a:extLst>
+              <a:ext uri="{FF2B5EF4-FFF2-40B4-BE49-F238E27FC236}">
+                <a16:creationId xmlns:a16="http://schemas.microsoft.com/office/drawing/2014/main" id="{B0535E65-BBF0-0E7C-783B-C298710FADAB}"/>
+              </a:ext>
+            </a:extLst>
+          </p:cNvPr>
+          <p:cNvPicPr>
+            <a:picLocks noChangeAspect="1" noChangeArrowheads="1"/>
+          </p:cNvPicPr>
+          <p:nvPr/>
+        </p:nvPicPr>
+        <p:blipFill>
+          <a:blip r:embed="rId3">
+            <a:extLst>
+              <a:ext uri="{28A0092B-C50C-407E-A947-70E740481C1C}">
+                <a14:useLocalDpi xmlns:a14="http://schemas.microsoft.com/office/drawing/2010/main" val="0"/>
+              </a:ext>
+            </a:extLst>
+          </a:blip>
+          <a:srcRect/>
+          <a:stretch>
+            <a:fillRect/>
+          </a:stretch>
+        </p:blipFill>
+        <p:spPr bwMode="auto">
+          <a:xfrm>
+            <a:off x="677536" y="4812537"/>
+            <a:ext cx="1068637" cy="1068637"/>
+          </a:xfrm>
+          <a:prstGeom prst="rect">
+            <a:avLst/>
+          </a:prstGeom>
+          <a:noFill/>
+          <a:extLst>
+            <a:ext uri="{909E8E84-426E-40DD-AFC4-6F175D3DCCD1}">
+              <a14:hiddenFill xmlns:a14="http://schemas.microsoft.com/office/drawing/2010/main">
+                <a:solidFill>
+                  <a:srgbClr val="FFFFFF"/>
+                </a:solidFill>
+              </a14:hiddenFill>
+            </a:ext>
+          </a:extLst>
+        </p:spPr>
+      </p:pic>
+      <p:sp>
+        <p:nvSpPr>
+          <p:cNvPr id="20" name="TextBox 19">
+            <a:extLst>
+              <a:ext uri="{FF2B5EF4-FFF2-40B4-BE49-F238E27FC236}">
+                <a16:creationId xmlns:a16="http://schemas.microsoft.com/office/drawing/2014/main" id="{8DE30F04-FEE6-084E-171E-9AD3BE62B7B7}"/>
+              </a:ext>
+            </a:extLst>
+          </p:cNvPr>
+          <p:cNvSpPr txBox="1"/>
+          <p:nvPr/>
+        </p:nvSpPr>
+        <p:spPr>
+          <a:xfrm>
+            <a:off x="705079" y="2419026"/>
+            <a:ext cx="1540806" cy="307777"/>
+          </a:xfrm>
+          <a:prstGeom prst="rect">
+            <a:avLst/>
+          </a:prstGeom>
+          <a:noFill/>
+        </p:spPr>
+        <p:txBody>
+          <a:bodyPr wrap="none" rtlCol="0">
+            <a:spAutoFit/>
+          </a:bodyPr>
+          <a:lstStyle/>
+          <a:p>
+            <a:r>
+              <a:rPr lang="en-US" sz="1400" dirty="0">
+                <a:latin typeface="IBM Plex Sans ExtLt" panose="020B0303050203000203" pitchFamily="34" charset="0"/>
+              </a:rPr>
+              <a:t>agent @ 1:27 pm</a:t>
+            </a:r>
+          </a:p>
+        </p:txBody>
+      </p:sp>
+      <p:sp>
+        <p:nvSpPr>
+          <p:cNvPr id="23" name="TextBox 22">
+            <a:extLst>
+              <a:ext uri="{FF2B5EF4-FFF2-40B4-BE49-F238E27FC236}">
+                <a16:creationId xmlns:a16="http://schemas.microsoft.com/office/drawing/2014/main" id="{971D717A-42C8-5118-E41E-4DAF2C3382BD}"/>
+              </a:ext>
+            </a:extLst>
+          </p:cNvPr>
+          <p:cNvSpPr txBox="1"/>
+          <p:nvPr/>
+        </p:nvSpPr>
+        <p:spPr>
+          <a:xfrm>
+            <a:off x="705079" y="4633416"/>
+            <a:ext cx="1540806" cy="307777"/>
+          </a:xfrm>
+          <a:prstGeom prst="rect">
+            <a:avLst/>
+          </a:prstGeom>
+          <a:noFill/>
+        </p:spPr>
+        <p:txBody>
+          <a:bodyPr wrap="none" rtlCol="0">
+            <a:spAutoFit/>
+          </a:bodyPr>
+          <a:lstStyle/>
+          <a:p>
+            <a:r>
+              <a:rPr lang="en-US" sz="1400" dirty="0">
+                <a:latin typeface="IBM Plex Sans ExtLt" panose="020B0303050203000203" pitchFamily="34" charset="0"/>
+              </a:rPr>
+              <a:t>agent @ 1:31 pm</a:t>
+            </a:r>
+          </a:p>
+        </p:txBody>
+      </p:sp>
+      <p:sp>
+        <p:nvSpPr>
+          <p:cNvPr id="25" name="Rounded Rectangular Callout 24">
+            <a:extLst>
+              <a:ext uri="{FF2B5EF4-FFF2-40B4-BE49-F238E27FC236}">
+                <a16:creationId xmlns:a16="http://schemas.microsoft.com/office/drawing/2014/main" id="{74DC42B2-D174-B89F-6230-0D8B075919CE}"/>
               </a:ext>
             </a:extLst>
           </p:cNvPr>
@@ -3723,8 +3928,8 @@
         </p:nvSpPr>
         <p:spPr>
           <a:xfrm>
-            <a:off x="7083846" y="2032478"/>
-            <a:ext cx="4124207" cy="594911"/>
+            <a:off x="8449939" y="2032478"/>
+            <a:ext cx="2934386" cy="594911"/>
           </a:xfrm>
           <a:prstGeom prst="wedgeRoundRectCallout">
             <a:avLst>
@@ -3767,9 +3972,9 @@
           <a:bodyPr rtlCol="0" anchor="ctr"/>
           <a:lstStyle/>
           <a:p>
-            <a:pPr algn="ctr"/>
-            <a:r>
-              <a:rPr lang="en-US" dirty="0">
+            <a:pPr algn="r"/>
+            <a:r>
+              <a:rPr lang="en-US" sz="1600" dirty="0">
                 <a:solidFill>
                   <a:sysClr val="windowText" lastClr="000000"/>
                 </a:solidFill>
@@ -3781,59 +3986,10 @@
       </p:sp>
       <p:sp>
         <p:nvSpPr>
-          <p:cNvPr id="14" name="TextBox 13">
-            <a:extLst>
-              <a:ext uri="{FF2B5EF4-FFF2-40B4-BE49-F238E27FC236}">
-                <a16:creationId xmlns:a16="http://schemas.microsoft.com/office/drawing/2014/main" id="{2BE66C0E-48CC-FF30-51E8-CB7A9ABDC741}"/>
-              </a:ext>
-            </a:extLst>
-          </p:cNvPr>
-          <p:cNvSpPr txBox="1"/>
-          <p:nvPr/>
-        </p:nvSpPr>
-        <p:spPr>
-          <a:xfrm>
-            <a:off x="705079" y="2750470"/>
-            <a:ext cx="4120309" cy="646331"/>
-          </a:xfrm>
-          <a:prstGeom prst="rect">
-            <a:avLst/>
-          </a:prstGeom>
-          <a:noFill/>
-        </p:spPr>
-        <p:txBody>
-          <a:bodyPr wrap="square" rtlCol="0">
-            <a:spAutoFit/>
-          </a:bodyPr>
-          <a:lstStyle/>
-          <a:p>
-            <a:r>
-              <a:rPr lang="en-US" dirty="0"/>
-              <a:t>Agent’s 1</a:t>
-            </a:r>
-            <a:r>
-              <a:rPr lang="en-US" baseline="30000" dirty="0"/>
-              <a:t>st</a:t>
-            </a:r>
-            <a:r>
-              <a:rPr lang="en-US" dirty="0"/>
-              <a:t> response in natural language</a:t>
-            </a:r>
-          </a:p>
-          <a:p>
-            <a:r>
-              <a:rPr lang="en-US" dirty="0"/>
-              <a:t>plus charts and graphs</a:t>
-            </a:r>
-          </a:p>
-        </p:txBody>
-      </p:sp>
-      <p:sp>
-        <p:nvSpPr>
-          <p:cNvPr id="15" name="Rounded Rectangular Callout 14">
-            <a:extLst>
-              <a:ext uri="{FF2B5EF4-FFF2-40B4-BE49-F238E27FC236}">
-                <a16:creationId xmlns:a16="http://schemas.microsoft.com/office/drawing/2014/main" id="{6AB44CDC-1AA4-2883-6C98-1CA87DF0D3E5}"/>
+          <p:cNvPr id="26" name="Rounded Rectangular Callout 25">
+            <a:extLst>
+              <a:ext uri="{FF2B5EF4-FFF2-40B4-BE49-F238E27FC236}">
+                <a16:creationId xmlns:a16="http://schemas.microsoft.com/office/drawing/2014/main" id="{7CFA3047-7451-DD22-5A35-D1731DCD4901}"/>
               </a:ext>
             </a:extLst>
           </p:cNvPr>
@@ -3842,8 +3998,8 @@
         </p:nvSpPr>
         <p:spPr>
           <a:xfrm>
-            <a:off x="7083846" y="3712684"/>
-            <a:ext cx="4124207" cy="594911"/>
+            <a:off x="8449939" y="3712684"/>
+            <a:ext cx="2934386" cy="594911"/>
           </a:xfrm>
           <a:prstGeom prst="wedgeRoundRectCallout">
             <a:avLst>
@@ -3886,9 +4042,9 @@
           <a:bodyPr rtlCol="0" anchor="ctr"/>
           <a:lstStyle/>
           <a:p>
-            <a:pPr algn="ctr"/>
-            <a:r>
-              <a:rPr lang="en-US" dirty="0">
+            <a:pPr algn="r"/>
+            <a:r>
+              <a:rPr lang="en-US" sz="1600" dirty="0">
                 <a:solidFill>
                   <a:sysClr val="windowText" lastClr="000000"/>
                 </a:solidFill>
@@ -3900,10 +4056,10 @@
       </p:sp>
       <p:sp>
         <p:nvSpPr>
-          <p:cNvPr id="16" name="TextBox 15">
-            <a:extLst>
-              <a:ext uri="{FF2B5EF4-FFF2-40B4-BE49-F238E27FC236}">
-                <a16:creationId xmlns:a16="http://schemas.microsoft.com/office/drawing/2014/main" id="{5F72A68A-E3D1-3878-9B1B-070098E84CF0}"/>
+          <p:cNvPr id="27" name="TextBox 26">
+            <a:extLst>
+              <a:ext uri="{FF2B5EF4-FFF2-40B4-BE49-F238E27FC236}">
+                <a16:creationId xmlns:a16="http://schemas.microsoft.com/office/drawing/2014/main" id="{5170A978-90C4-ED88-0C1D-0948505C0B19}"/>
               </a:ext>
             </a:extLst>
           </p:cNvPr>
@@ -3912,8 +4068,8 @@
         </p:nvSpPr>
         <p:spPr>
           <a:xfrm>
-            <a:off x="1608462" y="5023689"/>
-            <a:ext cx="4120309" cy="646331"/>
+            <a:off x="10003818" y="1719420"/>
+            <a:ext cx="1380507" cy="307777"/>
           </a:xfrm>
           <a:prstGeom prst="rect">
             <a:avLst/>
@@ -3921,124 +4077,42 @@
           <a:noFill/>
         </p:spPr>
         <p:txBody>
-          <a:bodyPr wrap="square" rtlCol="0">
+          <a:bodyPr wrap="none" rtlCol="0">
             <a:spAutoFit/>
           </a:bodyPr>
           <a:lstStyle/>
           <a:p>
-            <a:r>
-              <a:rPr lang="en-US" dirty="0"/>
-              <a:t>Please wait while the agent processes its response…</a:t>
-            </a:r>
-          </a:p>
-        </p:txBody>
-      </p:sp>
-      <p:pic>
-        <p:nvPicPr>
-          <p:cNvPr id="1026" name="Picture 2" descr="Please Wait Notepad Icons - Free SVG &amp; PNG Please Wait ...">
-            <a:extLst>
-              <a:ext uri="{FF2B5EF4-FFF2-40B4-BE49-F238E27FC236}">
-                <a16:creationId xmlns:a16="http://schemas.microsoft.com/office/drawing/2014/main" id="{B0535E65-BBF0-0E7C-783B-C298710FADAB}"/>
-              </a:ext>
-            </a:extLst>
-          </p:cNvPr>
-          <p:cNvPicPr>
-            <a:picLocks noChangeAspect="1" noChangeArrowheads="1"/>
-          </p:cNvPicPr>
+            <a:pPr algn="r"/>
+            <a:r>
+              <a:rPr lang="en-US" sz="1400" dirty="0">
+                <a:latin typeface="IBM Plex Sans ExtLt" panose="020B0303050203000203" pitchFamily="34" charset="0"/>
+              </a:rPr>
+              <a:t>you @ 1:25 pm</a:t>
+            </a:r>
+          </a:p>
+        </p:txBody>
+      </p:sp>
+      <p:sp>
+        <p:nvSpPr>
+          <p:cNvPr id="28" name="TextBox 27">
+            <a:extLst>
+              <a:ext uri="{FF2B5EF4-FFF2-40B4-BE49-F238E27FC236}">
+                <a16:creationId xmlns:a16="http://schemas.microsoft.com/office/drawing/2014/main" id="{12453BC1-A0DF-850E-C041-CEEDC9ED24A5}"/>
+              </a:ext>
+            </a:extLst>
+          </p:cNvPr>
+          <p:cNvSpPr txBox="1"/>
           <p:nvPr/>
-        </p:nvPicPr>
-        <p:blipFill>
-          <a:blip r:embed="rId3">
-            <a:extLst>
-              <a:ext uri="{28A0092B-C50C-407E-A947-70E740481C1C}">
-                <a14:useLocalDpi xmlns:a14="http://schemas.microsoft.com/office/drawing/2010/main" val="0"/>
-              </a:ext>
-            </a:extLst>
-          </a:blip>
-          <a:srcRect/>
-          <a:stretch>
-            <a:fillRect/>
-          </a:stretch>
-        </p:blipFill>
-        <p:spPr bwMode="auto">
-          <a:xfrm>
-            <a:off x="677536" y="4812537"/>
-            <a:ext cx="1068637" cy="1068637"/>
+        </p:nvSpPr>
+        <p:spPr>
+          <a:xfrm>
+            <a:off x="10003818" y="3393983"/>
+            <a:ext cx="1380507" cy="307777"/>
           </a:xfrm>
           <a:prstGeom prst="rect">
             <a:avLst/>
           </a:prstGeom>
           <a:noFill/>
-          <a:extLst>
-            <a:ext uri="{909E8E84-426E-40DD-AFC4-6F175D3DCCD1}">
-              <a14:hiddenFill xmlns:a14="http://schemas.microsoft.com/office/drawing/2010/main">
-                <a:solidFill>
-                  <a:srgbClr val="FFFFFF"/>
-                </a:solidFill>
-              </a14:hiddenFill>
-            </a:ext>
-          </a:extLst>
-        </p:spPr>
-      </p:pic>
-      <p:sp>
-        <p:nvSpPr>
-          <p:cNvPr id="18" name="TextBox 17">
-            <a:extLst>
-              <a:ext uri="{FF2B5EF4-FFF2-40B4-BE49-F238E27FC236}">
-                <a16:creationId xmlns:a16="http://schemas.microsoft.com/office/drawing/2014/main" id="{FD87CE00-9ED5-2CA4-C276-06E34616EFA6}"/>
-              </a:ext>
-            </a:extLst>
-          </p:cNvPr>
-          <p:cNvSpPr txBox="1"/>
-          <p:nvPr/>
-        </p:nvSpPr>
-        <p:spPr>
-          <a:xfrm>
-            <a:off x="9827546" y="1719420"/>
-            <a:ext cx="1380507" cy="307777"/>
-          </a:xfrm>
-          <a:prstGeom prst="rect">
-            <a:avLst/>
-          </a:prstGeom>
-          <a:noFill/>
-        </p:spPr>
-        <p:txBody>
-          <a:bodyPr wrap="none" rtlCol="0">
-            <a:spAutoFit/>
-          </a:bodyPr>
-          <a:lstStyle/>
-          <a:p>
-            <a:pPr algn="r"/>
-            <a:r>
-              <a:rPr lang="en-US" sz="1400" dirty="0">
-                <a:latin typeface="IBM Plex Sans ExtLt" panose="020B0303050203000203" pitchFamily="34" charset="0"/>
-              </a:rPr>
-              <a:t>you @ 1:25 pm</a:t>
-            </a:r>
-          </a:p>
-        </p:txBody>
-      </p:sp>
-      <p:sp>
-        <p:nvSpPr>
-          <p:cNvPr id="19" name="TextBox 18">
-            <a:extLst>
-              <a:ext uri="{FF2B5EF4-FFF2-40B4-BE49-F238E27FC236}">
-                <a16:creationId xmlns:a16="http://schemas.microsoft.com/office/drawing/2014/main" id="{F8D50FE9-0171-DCB8-6341-CD94689E526B}"/>
-              </a:ext>
-            </a:extLst>
-          </p:cNvPr>
-          <p:cNvSpPr txBox="1"/>
-          <p:nvPr/>
-        </p:nvSpPr>
-        <p:spPr>
-          <a:xfrm>
-            <a:off x="9827546" y="3393983"/>
-            <a:ext cx="1380507" cy="307777"/>
-          </a:xfrm>
-          <a:prstGeom prst="rect">
-            <a:avLst/>
-          </a:prstGeom>
-          <a:noFill/>
         </p:spPr>
         <p:txBody>
           <a:bodyPr wrap="none" rtlCol="0">
@@ -4052,80 +4126,6 @@
                 <a:latin typeface="IBM Plex Sans ExtLt" panose="020B0303050203000203" pitchFamily="34" charset="0"/>
               </a:rPr>
               <a:t>you @ 1:30 pm</a:t>
-            </a:r>
-          </a:p>
-        </p:txBody>
-      </p:sp>
-      <p:sp>
-        <p:nvSpPr>
-          <p:cNvPr id="20" name="TextBox 19">
-            <a:extLst>
-              <a:ext uri="{FF2B5EF4-FFF2-40B4-BE49-F238E27FC236}">
-                <a16:creationId xmlns:a16="http://schemas.microsoft.com/office/drawing/2014/main" id="{8DE30F04-FEE6-084E-171E-9AD3BE62B7B7}"/>
-              </a:ext>
-            </a:extLst>
-          </p:cNvPr>
-          <p:cNvSpPr txBox="1"/>
-          <p:nvPr/>
-        </p:nvSpPr>
-        <p:spPr>
-          <a:xfrm>
-            <a:off x="705079" y="2419026"/>
-            <a:ext cx="1540806" cy="307777"/>
-          </a:xfrm>
-          <a:prstGeom prst="rect">
-            <a:avLst/>
-          </a:prstGeom>
-          <a:noFill/>
-        </p:spPr>
-        <p:txBody>
-          <a:bodyPr wrap="none" rtlCol="0">
-            <a:spAutoFit/>
-          </a:bodyPr>
-          <a:lstStyle/>
-          <a:p>
-            <a:r>
-              <a:rPr lang="en-US" sz="1400" dirty="0">
-                <a:latin typeface="IBM Plex Sans ExtLt" panose="020B0303050203000203" pitchFamily="34" charset="0"/>
-              </a:rPr>
-              <a:t>agent @ 1:27 pm</a:t>
-            </a:r>
-          </a:p>
-        </p:txBody>
-      </p:sp>
-      <p:sp>
-        <p:nvSpPr>
-          <p:cNvPr id="23" name="TextBox 22">
-            <a:extLst>
-              <a:ext uri="{FF2B5EF4-FFF2-40B4-BE49-F238E27FC236}">
-                <a16:creationId xmlns:a16="http://schemas.microsoft.com/office/drawing/2014/main" id="{971D717A-42C8-5118-E41E-4DAF2C3382BD}"/>
-              </a:ext>
-            </a:extLst>
-          </p:cNvPr>
-          <p:cNvSpPr txBox="1"/>
-          <p:nvPr/>
-        </p:nvSpPr>
-        <p:spPr>
-          <a:xfrm>
-            <a:off x="705079" y="4633416"/>
-            <a:ext cx="1540806" cy="307777"/>
-          </a:xfrm>
-          <a:prstGeom prst="rect">
-            <a:avLst/>
-          </a:prstGeom>
-          <a:noFill/>
-        </p:spPr>
-        <p:txBody>
-          <a:bodyPr wrap="none" rtlCol="0">
-            <a:spAutoFit/>
-          </a:bodyPr>
-          <a:lstStyle/>
-          <a:p>
-            <a:r>
-              <a:rPr lang="en-US" sz="1400" dirty="0">
-                <a:latin typeface="IBM Plex Sans ExtLt" panose="020B0303050203000203" pitchFamily="34" charset="0"/>
-              </a:rPr>
-              <a:t>agent @ 1:31 pm</a:t>
             </a:r>
           </a:p>
         </p:txBody>
@@ -4555,8 +4555,8 @@
         </p:nvSpPr>
         <p:spPr>
           <a:xfrm>
-            <a:off x="7083846" y="2032478"/>
-            <a:ext cx="4124207" cy="594911"/>
+            <a:off x="8449939" y="2032478"/>
+            <a:ext cx="2934386" cy="594911"/>
           </a:xfrm>
           <a:prstGeom prst="wedgeRoundRectCallout">
             <a:avLst>
@@ -4599,9 +4599,9 @@
           <a:bodyPr rtlCol="0" anchor="ctr"/>
           <a:lstStyle/>
           <a:p>
-            <a:pPr algn="ctr"/>
-            <a:r>
-              <a:rPr lang="en-US" dirty="0">
+            <a:pPr algn="r"/>
+            <a:r>
+              <a:rPr lang="en-US" sz="1600" dirty="0">
                 <a:solidFill>
                   <a:sysClr val="windowText" lastClr="000000"/>
                 </a:solidFill>
@@ -4626,7 +4626,7 @@
         <p:spPr>
           <a:xfrm>
             <a:off x="705079" y="2750470"/>
-            <a:ext cx="4120309" cy="646331"/>
+            <a:ext cx="4120309" cy="584775"/>
           </a:xfrm>
           <a:prstGeom prst="rect">
             <a:avLst/>
@@ -4640,21 +4640,21 @@
           <a:lstStyle/>
           <a:p>
             <a:r>
-              <a:rPr lang="en-US" dirty="0"/>
+              <a:rPr lang="en-US" sz="1600" dirty="0"/>
               <a:t>Agent’s 1</a:t>
             </a:r>
             <a:r>
-              <a:rPr lang="en-US" baseline="30000" dirty="0"/>
+              <a:rPr lang="en-US" sz="1600" baseline="30000" dirty="0"/>
               <a:t>st</a:t>
             </a:r>
             <a:r>
-              <a:rPr lang="en-US" dirty="0"/>
+              <a:rPr lang="en-US" sz="1600" dirty="0"/>
               <a:t> response in natural language</a:t>
             </a:r>
           </a:p>
           <a:p>
             <a:r>
-              <a:rPr lang="en-US" dirty="0"/>
+              <a:rPr lang="en-US" sz="1600" dirty="0"/>
               <a:t>plus charts and graphs</a:t>
             </a:r>
           </a:p>
@@ -4674,8 +4674,8 @@
         </p:nvSpPr>
         <p:spPr>
           <a:xfrm>
-            <a:off x="7083846" y="3712684"/>
-            <a:ext cx="4124207" cy="594911"/>
+            <a:off x="8449939" y="3712684"/>
+            <a:ext cx="2934386" cy="594911"/>
           </a:xfrm>
           <a:prstGeom prst="wedgeRoundRectCallout">
             <a:avLst>
@@ -4718,9 +4718,9 @@
           <a:bodyPr rtlCol="0" anchor="ctr"/>
           <a:lstStyle/>
           <a:p>
-            <a:pPr algn="ctr"/>
-            <a:r>
-              <a:rPr lang="en-US" dirty="0">
+            <a:pPr algn="r"/>
+            <a:r>
+              <a:rPr lang="en-US" sz="1600" dirty="0">
                 <a:solidFill>
                   <a:sysClr val="windowText" lastClr="000000"/>
                 </a:solidFill>
@@ -4745,7 +4745,7 @@
         <p:spPr>
           <a:xfrm>
             <a:off x="1608462" y="5023689"/>
-            <a:ext cx="4120309" cy="646331"/>
+            <a:ext cx="4120309" cy="584775"/>
           </a:xfrm>
           <a:prstGeom prst="rect">
             <a:avLst/>
@@ -4759,7 +4759,7 @@
           <a:lstStyle/>
           <a:p>
             <a:r>
-              <a:rPr lang="en-US" dirty="0"/>
+              <a:rPr lang="en-US" sz="1600" dirty="0"/>
               <a:t>Please wait while the agent processes its response…</a:t>
             </a:r>
           </a:p>
@@ -4826,7 +4826,7 @@
         </p:nvSpPr>
         <p:spPr>
           <a:xfrm>
-            <a:off x="9827546" y="1719420"/>
+            <a:off x="10003818" y="1719420"/>
             <a:ext cx="1380507" cy="307777"/>
           </a:xfrm>
           <a:prstGeom prst="rect">
@@ -4864,7 +4864,7 @@
         </p:nvSpPr>
         <p:spPr>
           <a:xfrm>
-            <a:off x="9827546" y="3393983"/>
+            <a:off x="10003818" y="3393983"/>
             <a:ext cx="1380507" cy="307777"/>
           </a:xfrm>
           <a:prstGeom prst="rect">
@@ -5497,10 +5497,105 @@
       </p:pic>
       <p:sp>
         <p:nvSpPr>
-          <p:cNvPr id="13" name="Rounded Rectangular Callout 12">
-            <a:extLst>
-              <a:ext uri="{FF2B5EF4-FFF2-40B4-BE49-F238E27FC236}">
-                <a16:creationId xmlns:a16="http://schemas.microsoft.com/office/drawing/2014/main" id="{ADD4E18E-8302-060C-7164-225F714931A0}"/>
+          <p:cNvPr id="14" name="TextBox 13">
+            <a:extLst>
+              <a:ext uri="{FF2B5EF4-FFF2-40B4-BE49-F238E27FC236}">
+                <a16:creationId xmlns:a16="http://schemas.microsoft.com/office/drawing/2014/main" id="{D2046497-0EE7-407A-AFB4-1D1EBBFB18D7}"/>
+              </a:ext>
+            </a:extLst>
+          </p:cNvPr>
+          <p:cNvSpPr txBox="1"/>
+          <p:nvPr/>
+        </p:nvSpPr>
+        <p:spPr>
+          <a:xfrm>
+            <a:off x="705079" y="3668896"/>
+            <a:ext cx="4120309" cy="584775"/>
+          </a:xfrm>
+          <a:prstGeom prst="rect">
+            <a:avLst/>
+          </a:prstGeom>
+          <a:noFill/>
+        </p:spPr>
+        <p:txBody>
+          <a:bodyPr wrap="square" rtlCol="0">
+            <a:spAutoFit/>
+          </a:bodyPr>
+          <a:lstStyle/>
+          <a:p>
+            <a:r>
+              <a:rPr lang="en-US" sz="1600" dirty="0"/>
+              <a:t>Agent’s 1</a:t>
+            </a:r>
+            <a:r>
+              <a:rPr lang="en-US" sz="1600" baseline="30000" dirty="0"/>
+              <a:t>st</a:t>
+            </a:r>
+            <a:r>
+              <a:rPr lang="en-US" sz="1600" dirty="0"/>
+              <a:t> response in natural language</a:t>
+            </a:r>
+          </a:p>
+          <a:p>
+            <a:r>
+              <a:rPr lang="en-US" sz="1600" dirty="0"/>
+              <a:t>plus charts and graphs</a:t>
+            </a:r>
+          </a:p>
+        </p:txBody>
+      </p:sp>
+      <p:sp>
+        <p:nvSpPr>
+          <p:cNvPr id="20" name="TextBox 19">
+            <a:extLst>
+              <a:ext uri="{FF2B5EF4-FFF2-40B4-BE49-F238E27FC236}">
+                <a16:creationId xmlns:a16="http://schemas.microsoft.com/office/drawing/2014/main" id="{52DED31F-B3EA-2616-51B2-AF0BE6534DAA}"/>
+              </a:ext>
+            </a:extLst>
+          </p:cNvPr>
+          <p:cNvSpPr txBox="1"/>
+          <p:nvPr/>
+        </p:nvSpPr>
+        <p:spPr>
+          <a:xfrm>
+            <a:off x="705079" y="2165636"/>
+            <a:ext cx="3461204" cy="307777"/>
+          </a:xfrm>
+          <a:prstGeom prst="rect">
+            <a:avLst/>
+          </a:prstGeom>
+          <a:noFill/>
+        </p:spPr>
+        <p:txBody>
+          <a:bodyPr wrap="none" rtlCol="0">
+            <a:spAutoFit/>
+          </a:bodyPr>
+          <a:lstStyle/>
+          <a:p>
+            <a:r>
+              <a:rPr lang="en-US" sz="1400" dirty="0">
+                <a:latin typeface="IBM Plex Sans ExtLt" panose="020B0303050203000203" pitchFamily="34" charset="0"/>
+              </a:rPr>
+              <a:t>agent @ 1:27 pm </a:t>
+            </a:r>
+            <a:r>
+              <a:rPr lang="en-US" sz="1400" dirty="0">
+                <a:solidFill>
+                  <a:schemeClr val="accent4"/>
+                </a:solidFill>
+                <a:latin typeface="IBM Plex Sans ExtLt" panose="020B0303050203000203" pitchFamily="34" charset="0"/>
+              </a:rPr>
+              <a:t>| Hide agent’s reasoning</a:t>
+            </a:r>
+          </a:p>
+        </p:txBody>
+      </p:sp>
+      <p:sp>
+        <p:nvSpPr>
+          <p:cNvPr id="22" name="Triangle 21">
+            <a:extLst>
+              <a:ext uri="{FF2B5EF4-FFF2-40B4-BE49-F238E27FC236}">
+                <a16:creationId xmlns:a16="http://schemas.microsoft.com/office/drawing/2014/main" id="{FF8CB2DD-3CB0-DEF4-1888-197E5A6CA3C1}"/>
               </a:ext>
             </a:extLst>
           </p:cNvPr>
@@ -5509,8 +5604,493 @@
         </p:nvSpPr>
         <p:spPr>
           <a:xfrm>
-            <a:off x="7083846" y="1779088"/>
-            <a:ext cx="4124207" cy="594911"/>
+            <a:off x="4142674" y="2247439"/>
+            <a:ext cx="171069" cy="139054"/>
+          </a:xfrm>
+          <a:prstGeom prst="triangle">
+            <a:avLst/>
+          </a:prstGeom>
+          <a:solidFill>
+            <a:schemeClr val="accent4">
+              <a:lumMod val="20000"/>
+              <a:lumOff val="80000"/>
+            </a:schemeClr>
+          </a:solidFill>
+          <a:ln>
+            <a:solidFill>
+              <a:schemeClr val="accent4"/>
+            </a:solidFill>
+          </a:ln>
+        </p:spPr>
+        <p:style>
+          <a:lnRef idx="2">
+            <a:schemeClr val="accent1">
+              <a:shade val="15000"/>
+            </a:schemeClr>
+          </a:lnRef>
+          <a:fillRef idx="1">
+            <a:schemeClr val="accent1"/>
+          </a:fillRef>
+          <a:effectRef idx="0">
+            <a:schemeClr val="accent1"/>
+          </a:effectRef>
+          <a:fontRef idx="minor">
+            <a:schemeClr val="lt1"/>
+          </a:fontRef>
+        </p:style>
+        <p:txBody>
+          <a:bodyPr rtlCol="0" anchor="ctr"/>
+          <a:lstStyle/>
+          <a:p>
+            <a:pPr algn="ctr"/>
+            <a:endParaRPr lang="en-US"/>
+          </a:p>
+        </p:txBody>
+      </p:sp>
+      <p:sp>
+        <p:nvSpPr>
+          <p:cNvPr id="3" name="TextBox 2">
+            <a:extLst>
+              <a:ext uri="{FF2B5EF4-FFF2-40B4-BE49-F238E27FC236}">
+                <a16:creationId xmlns:a16="http://schemas.microsoft.com/office/drawing/2014/main" id="{B67FD1F2-F809-85E8-7B31-D429F45912B2}"/>
+              </a:ext>
+            </a:extLst>
+          </p:cNvPr>
+          <p:cNvSpPr txBox="1"/>
+          <p:nvPr/>
+        </p:nvSpPr>
+        <p:spPr>
+          <a:xfrm>
+            <a:off x="1079653" y="2608760"/>
+            <a:ext cx="3778786" cy="892552"/>
+          </a:xfrm>
+          <a:prstGeom prst="rect">
+            <a:avLst/>
+          </a:prstGeom>
+          <a:noFill/>
+        </p:spPr>
+        <p:txBody>
+          <a:bodyPr wrap="square" rtlCol="0">
+            <a:spAutoFit/>
+          </a:bodyPr>
+          <a:lstStyle/>
+          <a:p>
+            <a:pPr>
+              <a:spcAft>
+                <a:spcPts val="600"/>
+              </a:spcAft>
+            </a:pPr>
+            <a:r>
+              <a:rPr lang="en-US" sz="1400" dirty="0">
+                <a:solidFill>
+                  <a:schemeClr val="accent4"/>
+                </a:solidFill>
+                <a:latin typeface="IBM Plex Sans ExtLt" panose="020B0303050203000203" pitchFamily="34" charset="0"/>
+              </a:rPr>
+              <a:t>Step 1</a:t>
+            </a:r>
+          </a:p>
+          <a:p>
+            <a:pPr>
+              <a:spcAft>
+                <a:spcPts val="600"/>
+              </a:spcAft>
+            </a:pPr>
+            <a:r>
+              <a:rPr lang="en-US" sz="1400" dirty="0">
+                <a:solidFill>
+                  <a:schemeClr val="accent4"/>
+                </a:solidFill>
+                <a:latin typeface="IBM Plex Sans ExtLt" panose="020B0303050203000203" pitchFamily="34" charset="0"/>
+              </a:rPr>
+              <a:t>Step 2</a:t>
+            </a:r>
+          </a:p>
+          <a:p>
+            <a:pPr>
+              <a:spcAft>
+                <a:spcPts val="600"/>
+              </a:spcAft>
+            </a:pPr>
+            <a:r>
+              <a:rPr lang="en-US" sz="1400" dirty="0">
+                <a:solidFill>
+                  <a:schemeClr val="accent4"/>
+                </a:solidFill>
+                <a:latin typeface="IBM Plex Sans ExtLt" panose="020B0303050203000203" pitchFamily="34" charset="0"/>
+              </a:rPr>
+              <a:t>Step 3</a:t>
+            </a:r>
+          </a:p>
+        </p:txBody>
+      </p:sp>
+      <p:sp>
+        <p:nvSpPr>
+          <p:cNvPr id="10" name="Triangle 9">
+            <a:extLst>
+              <a:ext uri="{FF2B5EF4-FFF2-40B4-BE49-F238E27FC236}">
+                <a16:creationId xmlns:a16="http://schemas.microsoft.com/office/drawing/2014/main" id="{7577DF1C-BFCE-87EB-8822-1658FE3A867F}"/>
+              </a:ext>
+            </a:extLst>
+          </p:cNvPr>
+          <p:cNvSpPr/>
+          <p:nvPr/>
+        </p:nvSpPr>
+        <p:spPr>
+          <a:xfrm rot="10800000">
+            <a:off x="908584" y="2695680"/>
+            <a:ext cx="171069" cy="139054"/>
+          </a:xfrm>
+          <a:prstGeom prst="triangle">
+            <a:avLst/>
+          </a:prstGeom>
+          <a:solidFill>
+            <a:schemeClr val="accent4">
+              <a:lumMod val="20000"/>
+              <a:lumOff val="80000"/>
+            </a:schemeClr>
+          </a:solidFill>
+          <a:ln>
+            <a:solidFill>
+              <a:schemeClr val="accent4"/>
+            </a:solidFill>
+          </a:ln>
+        </p:spPr>
+        <p:style>
+          <a:lnRef idx="2">
+            <a:schemeClr val="accent1">
+              <a:shade val="15000"/>
+            </a:schemeClr>
+          </a:lnRef>
+          <a:fillRef idx="1">
+            <a:schemeClr val="accent1"/>
+          </a:fillRef>
+          <a:effectRef idx="0">
+            <a:schemeClr val="accent1"/>
+          </a:effectRef>
+          <a:fontRef idx="minor">
+            <a:schemeClr val="lt1"/>
+          </a:fontRef>
+        </p:style>
+        <p:txBody>
+          <a:bodyPr rtlCol="0" anchor="ctr"/>
+          <a:lstStyle/>
+          <a:p>
+            <a:pPr algn="ctr"/>
+            <a:endParaRPr lang="en-US"/>
+          </a:p>
+        </p:txBody>
+      </p:sp>
+      <p:sp>
+        <p:nvSpPr>
+          <p:cNvPr id="11" name="Triangle 10">
+            <a:extLst>
+              <a:ext uri="{FF2B5EF4-FFF2-40B4-BE49-F238E27FC236}">
+                <a16:creationId xmlns:a16="http://schemas.microsoft.com/office/drawing/2014/main" id="{CBA69871-7994-9D13-A6D5-F0F5EF787368}"/>
+              </a:ext>
+            </a:extLst>
+          </p:cNvPr>
+          <p:cNvSpPr/>
+          <p:nvPr/>
+        </p:nvSpPr>
+        <p:spPr>
+          <a:xfrm rot="10800000">
+            <a:off x="917763" y="3002318"/>
+            <a:ext cx="171069" cy="139054"/>
+          </a:xfrm>
+          <a:prstGeom prst="triangle">
+            <a:avLst/>
+          </a:prstGeom>
+          <a:solidFill>
+            <a:schemeClr val="accent4">
+              <a:lumMod val="20000"/>
+              <a:lumOff val="80000"/>
+            </a:schemeClr>
+          </a:solidFill>
+          <a:ln>
+            <a:solidFill>
+              <a:schemeClr val="accent4"/>
+            </a:solidFill>
+          </a:ln>
+        </p:spPr>
+        <p:style>
+          <a:lnRef idx="2">
+            <a:schemeClr val="accent1">
+              <a:shade val="15000"/>
+            </a:schemeClr>
+          </a:lnRef>
+          <a:fillRef idx="1">
+            <a:schemeClr val="accent1"/>
+          </a:fillRef>
+          <a:effectRef idx="0">
+            <a:schemeClr val="accent1"/>
+          </a:effectRef>
+          <a:fontRef idx="minor">
+            <a:schemeClr val="lt1"/>
+          </a:fontRef>
+        </p:style>
+        <p:txBody>
+          <a:bodyPr rtlCol="0" anchor="ctr"/>
+          <a:lstStyle/>
+          <a:p>
+            <a:pPr algn="ctr"/>
+            <a:endParaRPr lang="en-US"/>
+          </a:p>
+        </p:txBody>
+      </p:sp>
+      <p:sp>
+        <p:nvSpPr>
+          <p:cNvPr id="17" name="Triangle 16">
+            <a:extLst>
+              <a:ext uri="{FF2B5EF4-FFF2-40B4-BE49-F238E27FC236}">
+                <a16:creationId xmlns:a16="http://schemas.microsoft.com/office/drawing/2014/main" id="{FB249469-8CFF-9510-F29D-9D36A8F65ED8}"/>
+              </a:ext>
+            </a:extLst>
+          </p:cNvPr>
+          <p:cNvSpPr/>
+          <p:nvPr/>
+        </p:nvSpPr>
+        <p:spPr>
+          <a:xfrm rot="10800000">
+            <a:off x="915925" y="3297939"/>
+            <a:ext cx="171069" cy="139054"/>
+          </a:xfrm>
+          <a:prstGeom prst="triangle">
+            <a:avLst/>
+          </a:prstGeom>
+          <a:solidFill>
+            <a:schemeClr val="accent4">
+              <a:lumMod val="20000"/>
+              <a:lumOff val="80000"/>
+            </a:schemeClr>
+          </a:solidFill>
+          <a:ln>
+            <a:solidFill>
+              <a:schemeClr val="accent4"/>
+            </a:solidFill>
+          </a:ln>
+        </p:spPr>
+        <p:style>
+          <a:lnRef idx="2">
+            <a:schemeClr val="accent1">
+              <a:shade val="15000"/>
+            </a:schemeClr>
+          </a:lnRef>
+          <a:fillRef idx="1">
+            <a:schemeClr val="accent1"/>
+          </a:fillRef>
+          <a:effectRef idx="0">
+            <a:schemeClr val="accent1"/>
+          </a:effectRef>
+          <a:fontRef idx="minor">
+            <a:schemeClr val="lt1"/>
+          </a:fontRef>
+        </p:style>
+        <p:txBody>
+          <a:bodyPr rtlCol="0" anchor="ctr"/>
+          <a:lstStyle/>
+          <a:p>
+            <a:pPr algn="ctr"/>
+            <a:endParaRPr lang="en-US"/>
+          </a:p>
+        </p:txBody>
+      </p:sp>
+      <p:sp>
+        <p:nvSpPr>
+          <p:cNvPr id="21" name="TextBox 20">
+            <a:extLst>
+              <a:ext uri="{FF2B5EF4-FFF2-40B4-BE49-F238E27FC236}">
+                <a16:creationId xmlns:a16="http://schemas.microsoft.com/office/drawing/2014/main" id="{3AB2F13F-0AD1-A74F-D5FC-ED7517B566C4}"/>
+              </a:ext>
+            </a:extLst>
+          </p:cNvPr>
+          <p:cNvSpPr txBox="1"/>
+          <p:nvPr/>
+        </p:nvSpPr>
+        <p:spPr>
+          <a:xfrm>
+            <a:off x="1636005" y="5310809"/>
+            <a:ext cx="4120309" cy="584775"/>
+          </a:xfrm>
+          <a:prstGeom prst="rect">
+            <a:avLst/>
+          </a:prstGeom>
+          <a:noFill/>
+        </p:spPr>
+        <p:txBody>
+          <a:bodyPr wrap="square" rtlCol="0">
+            <a:spAutoFit/>
+          </a:bodyPr>
+          <a:lstStyle/>
+          <a:p>
+            <a:r>
+              <a:rPr lang="en-US" sz="1600" dirty="0"/>
+              <a:t>Please wait while the agent processes its response…</a:t>
+            </a:r>
+          </a:p>
+        </p:txBody>
+      </p:sp>
+      <p:pic>
+        <p:nvPicPr>
+          <p:cNvPr id="25" name="Picture 2" descr="Please Wait Notepad Icons - Free SVG &amp; PNG Please Wait ...">
+            <a:extLst>
+              <a:ext uri="{FF2B5EF4-FFF2-40B4-BE49-F238E27FC236}">
+                <a16:creationId xmlns:a16="http://schemas.microsoft.com/office/drawing/2014/main" id="{41DD67B2-06BE-8845-FFFC-2066F45E657E}"/>
+              </a:ext>
+            </a:extLst>
+          </p:cNvPr>
+          <p:cNvPicPr>
+            <a:picLocks noChangeAspect="1" noChangeArrowheads="1"/>
+          </p:cNvPicPr>
+          <p:nvPr/>
+        </p:nvPicPr>
+        <p:blipFill>
+          <a:blip r:embed="rId3">
+            <a:extLst>
+              <a:ext uri="{28A0092B-C50C-407E-A947-70E740481C1C}">
+                <a14:useLocalDpi xmlns:a14="http://schemas.microsoft.com/office/drawing/2010/main" val="0"/>
+              </a:ext>
+            </a:extLst>
+          </a:blip>
+          <a:srcRect/>
+          <a:stretch>
+            <a:fillRect/>
+          </a:stretch>
+        </p:blipFill>
+        <p:spPr bwMode="auto">
+          <a:xfrm>
+            <a:off x="705079" y="5099657"/>
+            <a:ext cx="1068637" cy="1068637"/>
+          </a:xfrm>
+          <a:prstGeom prst="rect">
+            <a:avLst/>
+          </a:prstGeom>
+          <a:noFill/>
+          <a:extLst>
+            <a:ext uri="{909E8E84-426E-40DD-AFC4-6F175D3DCCD1}">
+              <a14:hiddenFill xmlns:a14="http://schemas.microsoft.com/office/drawing/2010/main">
+                <a:solidFill>
+                  <a:srgbClr val="FFFFFF"/>
+                </a:solidFill>
+              </a14:hiddenFill>
+            </a:ext>
+          </a:extLst>
+        </p:spPr>
+      </p:pic>
+      <p:sp>
+        <p:nvSpPr>
+          <p:cNvPr id="26" name="TextBox 25">
+            <a:extLst>
+              <a:ext uri="{FF2B5EF4-FFF2-40B4-BE49-F238E27FC236}">
+                <a16:creationId xmlns:a16="http://schemas.microsoft.com/office/drawing/2014/main" id="{D7682D0D-E7D8-C1EA-C45B-23E3673406B7}"/>
+              </a:ext>
+            </a:extLst>
+          </p:cNvPr>
+          <p:cNvSpPr txBox="1"/>
+          <p:nvPr/>
+        </p:nvSpPr>
+        <p:spPr>
+          <a:xfrm>
+            <a:off x="732622" y="4920536"/>
+            <a:ext cx="3525324" cy="307777"/>
+          </a:xfrm>
+          <a:prstGeom prst="rect">
+            <a:avLst/>
+          </a:prstGeom>
+          <a:noFill/>
+        </p:spPr>
+        <p:txBody>
+          <a:bodyPr wrap="none" rtlCol="0">
+            <a:spAutoFit/>
+          </a:bodyPr>
+          <a:lstStyle/>
+          <a:p>
+            <a:r>
+              <a:rPr lang="en-US" sz="1400" dirty="0">
+                <a:latin typeface="IBM Plex Sans ExtLt" panose="020B0303050203000203" pitchFamily="34" charset="0"/>
+              </a:rPr>
+              <a:t>agent @ 1:31 pm</a:t>
+            </a:r>
+            <a:r>
+              <a:rPr lang="en-US" sz="1400" dirty="0">
+                <a:solidFill>
+                  <a:schemeClr val="accent4"/>
+                </a:solidFill>
+                <a:latin typeface="IBM Plex Sans ExtLt" panose="020B0303050203000203" pitchFamily="34" charset="0"/>
+              </a:rPr>
+              <a:t> | Show agent’s reasoning</a:t>
+            </a:r>
+          </a:p>
+        </p:txBody>
+      </p:sp>
+      <p:sp>
+        <p:nvSpPr>
+          <p:cNvPr id="27" name="Triangle 26">
+            <a:extLst>
+              <a:ext uri="{FF2B5EF4-FFF2-40B4-BE49-F238E27FC236}">
+                <a16:creationId xmlns:a16="http://schemas.microsoft.com/office/drawing/2014/main" id="{7E2DBCA6-9C95-C39C-75FC-2145E80C7DF6}"/>
+              </a:ext>
+            </a:extLst>
+          </p:cNvPr>
+          <p:cNvSpPr/>
+          <p:nvPr/>
+        </p:nvSpPr>
+        <p:spPr>
+          <a:xfrm rot="10800000">
+            <a:off x="4170217" y="5013356"/>
+            <a:ext cx="171069" cy="139054"/>
+          </a:xfrm>
+          <a:prstGeom prst="triangle">
+            <a:avLst/>
+          </a:prstGeom>
+          <a:solidFill>
+            <a:schemeClr val="accent4">
+              <a:lumMod val="20000"/>
+              <a:lumOff val="80000"/>
+            </a:schemeClr>
+          </a:solidFill>
+        </p:spPr>
+        <p:style>
+          <a:lnRef idx="2">
+            <a:schemeClr val="accent1">
+              <a:shade val="15000"/>
+            </a:schemeClr>
+          </a:lnRef>
+          <a:fillRef idx="1">
+            <a:schemeClr val="accent1"/>
+          </a:fillRef>
+          <a:effectRef idx="0">
+            <a:schemeClr val="accent1"/>
+          </a:effectRef>
+          <a:fontRef idx="minor">
+            <a:schemeClr val="lt1"/>
+          </a:fontRef>
+        </p:style>
+        <p:txBody>
+          <a:bodyPr rtlCol="0" anchor="ctr"/>
+          <a:lstStyle/>
+          <a:p>
+            <a:pPr algn="ctr"/>
+            <a:endParaRPr lang="en-US"/>
+          </a:p>
+        </p:txBody>
+      </p:sp>
+      <p:sp>
+        <p:nvSpPr>
+          <p:cNvPr id="28" name="Rounded Rectangular Callout 27">
+            <a:extLst>
+              <a:ext uri="{FF2B5EF4-FFF2-40B4-BE49-F238E27FC236}">
+                <a16:creationId xmlns:a16="http://schemas.microsoft.com/office/drawing/2014/main" id="{D7B37DE2-CBB5-4B05-C718-F0DFC62FAE74}"/>
+              </a:ext>
+            </a:extLst>
+          </p:cNvPr>
+          <p:cNvSpPr/>
+          <p:nvPr/>
+        </p:nvSpPr>
+        <p:spPr>
+          <a:xfrm>
+            <a:off x="8449939" y="1823155"/>
+            <a:ext cx="2934386" cy="594911"/>
           </a:xfrm>
           <a:prstGeom prst="wedgeRoundRectCallout">
             <a:avLst>
@@ -5553,9 +6133,9 @@
           <a:bodyPr rtlCol="0" anchor="ctr"/>
           <a:lstStyle/>
           <a:p>
-            <a:pPr algn="ctr"/>
-            <a:r>
-              <a:rPr lang="en-US" dirty="0">
+            <a:pPr algn="r"/>
+            <a:r>
+              <a:rPr lang="en-US" sz="1600" dirty="0">
                 <a:solidFill>
                   <a:sysClr val="windowText" lastClr="000000"/>
                 </a:solidFill>
@@ -5567,59 +6147,10 @@
       </p:sp>
       <p:sp>
         <p:nvSpPr>
-          <p:cNvPr id="14" name="TextBox 13">
-            <a:extLst>
-              <a:ext uri="{FF2B5EF4-FFF2-40B4-BE49-F238E27FC236}">
-                <a16:creationId xmlns:a16="http://schemas.microsoft.com/office/drawing/2014/main" id="{D2046497-0EE7-407A-AFB4-1D1EBBFB18D7}"/>
-              </a:ext>
-            </a:extLst>
-          </p:cNvPr>
-          <p:cNvSpPr txBox="1"/>
-          <p:nvPr/>
-        </p:nvSpPr>
-        <p:spPr>
-          <a:xfrm>
-            <a:off x="705079" y="3668896"/>
-            <a:ext cx="4120309" cy="646331"/>
-          </a:xfrm>
-          <a:prstGeom prst="rect">
-            <a:avLst/>
-          </a:prstGeom>
-          <a:noFill/>
-        </p:spPr>
-        <p:txBody>
-          <a:bodyPr wrap="square" rtlCol="0">
-            <a:spAutoFit/>
-          </a:bodyPr>
-          <a:lstStyle/>
-          <a:p>
-            <a:r>
-              <a:rPr lang="en-US" dirty="0"/>
-              <a:t>Agent’s 1</a:t>
-            </a:r>
-            <a:r>
-              <a:rPr lang="en-US" baseline="30000" dirty="0"/>
-              <a:t>st</a:t>
-            </a:r>
-            <a:r>
-              <a:rPr lang="en-US" dirty="0"/>
-              <a:t> response in natural language</a:t>
-            </a:r>
-          </a:p>
-          <a:p>
-            <a:r>
-              <a:rPr lang="en-US" dirty="0"/>
-              <a:t>plus charts and graphs</a:t>
-            </a:r>
-          </a:p>
-        </p:txBody>
-      </p:sp>
-      <p:sp>
-        <p:nvSpPr>
-          <p:cNvPr id="15" name="Rounded Rectangular Callout 14">
-            <a:extLst>
-              <a:ext uri="{FF2B5EF4-FFF2-40B4-BE49-F238E27FC236}">
-                <a16:creationId xmlns:a16="http://schemas.microsoft.com/office/drawing/2014/main" id="{277CA6D0-263C-A607-8C01-1850F7E2E3B0}"/>
+          <p:cNvPr id="29" name="Rounded Rectangular Callout 28">
+            <a:extLst>
+              <a:ext uri="{FF2B5EF4-FFF2-40B4-BE49-F238E27FC236}">
+                <a16:creationId xmlns:a16="http://schemas.microsoft.com/office/drawing/2014/main" id="{C69FFC27-77BE-D795-D24D-9D4AFEF529C6}"/>
               </a:ext>
             </a:extLst>
           </p:cNvPr>
@@ -5628,8 +6159,8 @@
         </p:nvSpPr>
         <p:spPr>
           <a:xfrm>
-            <a:off x="7083846" y="4315295"/>
-            <a:ext cx="4124207" cy="594911"/>
+            <a:off x="8449939" y="4329628"/>
+            <a:ext cx="2934386" cy="594911"/>
           </a:xfrm>
           <a:prstGeom prst="wedgeRoundRectCallout">
             <a:avLst>
@@ -5672,9 +6203,9 @@
           <a:bodyPr rtlCol="0" anchor="ctr"/>
           <a:lstStyle/>
           <a:p>
-            <a:pPr algn="ctr"/>
-            <a:r>
-              <a:rPr lang="en-US" dirty="0">
+            <a:pPr algn="r"/>
+            <a:r>
+              <a:rPr lang="en-US" sz="1600" dirty="0">
                 <a:solidFill>
                   <a:sysClr val="windowText" lastClr="000000"/>
                 </a:solidFill>
@@ -5686,10 +6217,10 @@
       </p:sp>
       <p:sp>
         <p:nvSpPr>
-          <p:cNvPr id="18" name="TextBox 17">
-            <a:extLst>
-              <a:ext uri="{FF2B5EF4-FFF2-40B4-BE49-F238E27FC236}">
-                <a16:creationId xmlns:a16="http://schemas.microsoft.com/office/drawing/2014/main" id="{EF3F711F-1810-FBBF-F043-E49F00195389}"/>
+          <p:cNvPr id="30" name="TextBox 29">
+            <a:extLst>
+              <a:ext uri="{FF2B5EF4-FFF2-40B4-BE49-F238E27FC236}">
+                <a16:creationId xmlns:a16="http://schemas.microsoft.com/office/drawing/2014/main" id="{C775A9CC-63E0-88CA-D9A3-1616A17CB2F2}"/>
               </a:ext>
             </a:extLst>
           </p:cNvPr>
@@ -5698,7 +6229,7 @@
         </p:nvSpPr>
         <p:spPr>
           <a:xfrm>
-            <a:off x="9827546" y="1466030"/>
+            <a:off x="10003818" y="1510097"/>
             <a:ext cx="1380507" cy="307777"/>
           </a:xfrm>
           <a:prstGeom prst="rect">
@@ -5724,10 +6255,10 @@
       </p:sp>
       <p:sp>
         <p:nvSpPr>
-          <p:cNvPr id="19" name="TextBox 18">
-            <a:extLst>
-              <a:ext uri="{FF2B5EF4-FFF2-40B4-BE49-F238E27FC236}">
-                <a16:creationId xmlns:a16="http://schemas.microsoft.com/office/drawing/2014/main" id="{2A12DD1E-C552-FD1F-D390-52544FDE1F3C}"/>
+          <p:cNvPr id="31" name="TextBox 30">
+            <a:extLst>
+              <a:ext uri="{FF2B5EF4-FFF2-40B4-BE49-F238E27FC236}">
+                <a16:creationId xmlns:a16="http://schemas.microsoft.com/office/drawing/2014/main" id="{A71129E8-57E1-9566-9755-57789A85A69D}"/>
               </a:ext>
             </a:extLst>
           </p:cNvPr>
@@ -5736,7 +6267,7 @@
         </p:nvSpPr>
         <p:spPr>
           <a:xfrm>
-            <a:off x="9827546" y="3996594"/>
+            <a:off x="10003818" y="4010927"/>
             <a:ext cx="1380507" cy="307777"/>
           </a:xfrm>
           <a:prstGeom prst="rect">
@@ -5757,537 +6288,6 @@
               </a:rPr>
               <a:t>you @ 1:30 pm</a:t>
             </a:r>
-          </a:p>
-        </p:txBody>
-      </p:sp>
-      <p:sp>
-        <p:nvSpPr>
-          <p:cNvPr id="20" name="TextBox 19">
-            <a:extLst>
-              <a:ext uri="{FF2B5EF4-FFF2-40B4-BE49-F238E27FC236}">
-                <a16:creationId xmlns:a16="http://schemas.microsoft.com/office/drawing/2014/main" id="{52DED31F-B3EA-2616-51B2-AF0BE6534DAA}"/>
-              </a:ext>
-            </a:extLst>
-          </p:cNvPr>
-          <p:cNvSpPr txBox="1"/>
-          <p:nvPr/>
-        </p:nvSpPr>
-        <p:spPr>
-          <a:xfrm>
-            <a:off x="705079" y="2165636"/>
-            <a:ext cx="3461204" cy="307777"/>
-          </a:xfrm>
-          <a:prstGeom prst="rect">
-            <a:avLst/>
-          </a:prstGeom>
-          <a:noFill/>
-        </p:spPr>
-        <p:txBody>
-          <a:bodyPr wrap="none" rtlCol="0">
-            <a:spAutoFit/>
-          </a:bodyPr>
-          <a:lstStyle/>
-          <a:p>
-            <a:r>
-              <a:rPr lang="en-US" sz="1400" dirty="0">
-                <a:latin typeface="IBM Plex Sans ExtLt" panose="020B0303050203000203" pitchFamily="34" charset="0"/>
-              </a:rPr>
-              <a:t>agent @ 1:27 pm </a:t>
-            </a:r>
-            <a:r>
-              <a:rPr lang="en-US" sz="1400" dirty="0">
-                <a:solidFill>
-                  <a:schemeClr val="accent4"/>
-                </a:solidFill>
-                <a:latin typeface="IBM Plex Sans ExtLt" panose="020B0303050203000203" pitchFamily="34" charset="0"/>
-              </a:rPr>
-              <a:t>| Hide agent’s reasoning</a:t>
-            </a:r>
-          </a:p>
-        </p:txBody>
-      </p:sp>
-      <p:sp>
-        <p:nvSpPr>
-          <p:cNvPr id="22" name="Triangle 21">
-            <a:extLst>
-              <a:ext uri="{FF2B5EF4-FFF2-40B4-BE49-F238E27FC236}">
-                <a16:creationId xmlns:a16="http://schemas.microsoft.com/office/drawing/2014/main" id="{FF8CB2DD-3CB0-DEF4-1888-197E5A6CA3C1}"/>
-              </a:ext>
-            </a:extLst>
-          </p:cNvPr>
-          <p:cNvSpPr/>
-          <p:nvPr/>
-        </p:nvSpPr>
-        <p:spPr>
-          <a:xfrm>
-            <a:off x="4142674" y="2247439"/>
-            <a:ext cx="171069" cy="139054"/>
-          </a:xfrm>
-          <a:prstGeom prst="triangle">
-            <a:avLst/>
-          </a:prstGeom>
-          <a:solidFill>
-            <a:schemeClr val="accent4">
-              <a:lumMod val="20000"/>
-              <a:lumOff val="80000"/>
-            </a:schemeClr>
-          </a:solidFill>
-          <a:ln>
-            <a:solidFill>
-              <a:schemeClr val="accent4"/>
-            </a:solidFill>
-          </a:ln>
-        </p:spPr>
-        <p:style>
-          <a:lnRef idx="2">
-            <a:schemeClr val="accent1">
-              <a:shade val="15000"/>
-            </a:schemeClr>
-          </a:lnRef>
-          <a:fillRef idx="1">
-            <a:schemeClr val="accent1"/>
-          </a:fillRef>
-          <a:effectRef idx="0">
-            <a:schemeClr val="accent1"/>
-          </a:effectRef>
-          <a:fontRef idx="minor">
-            <a:schemeClr val="lt1"/>
-          </a:fontRef>
-        </p:style>
-        <p:txBody>
-          <a:bodyPr rtlCol="0" anchor="ctr"/>
-          <a:lstStyle/>
-          <a:p>
-            <a:pPr algn="ctr"/>
-            <a:endParaRPr lang="en-US"/>
-          </a:p>
-        </p:txBody>
-      </p:sp>
-      <p:sp>
-        <p:nvSpPr>
-          <p:cNvPr id="3" name="TextBox 2">
-            <a:extLst>
-              <a:ext uri="{FF2B5EF4-FFF2-40B4-BE49-F238E27FC236}">
-                <a16:creationId xmlns:a16="http://schemas.microsoft.com/office/drawing/2014/main" id="{B67FD1F2-F809-85E8-7B31-D429F45912B2}"/>
-              </a:ext>
-            </a:extLst>
-          </p:cNvPr>
-          <p:cNvSpPr txBox="1"/>
-          <p:nvPr/>
-        </p:nvSpPr>
-        <p:spPr>
-          <a:xfrm>
-            <a:off x="1079653" y="2608760"/>
-            <a:ext cx="3778786" cy="892552"/>
-          </a:xfrm>
-          <a:prstGeom prst="rect">
-            <a:avLst/>
-          </a:prstGeom>
-          <a:noFill/>
-        </p:spPr>
-        <p:txBody>
-          <a:bodyPr wrap="square" rtlCol="0">
-            <a:spAutoFit/>
-          </a:bodyPr>
-          <a:lstStyle/>
-          <a:p>
-            <a:pPr>
-              <a:spcAft>
-                <a:spcPts val="600"/>
-              </a:spcAft>
-            </a:pPr>
-            <a:r>
-              <a:rPr lang="en-US" sz="1400" dirty="0">
-                <a:solidFill>
-                  <a:schemeClr val="accent4"/>
-                </a:solidFill>
-                <a:latin typeface="IBM Plex Sans ExtLt" panose="020B0303050203000203" pitchFamily="34" charset="0"/>
-              </a:rPr>
-              <a:t>Step 1</a:t>
-            </a:r>
-          </a:p>
-          <a:p>
-            <a:pPr>
-              <a:spcAft>
-                <a:spcPts val="600"/>
-              </a:spcAft>
-            </a:pPr>
-            <a:r>
-              <a:rPr lang="en-US" sz="1400" dirty="0">
-                <a:solidFill>
-                  <a:schemeClr val="accent4"/>
-                </a:solidFill>
-                <a:latin typeface="IBM Plex Sans ExtLt" panose="020B0303050203000203" pitchFamily="34" charset="0"/>
-              </a:rPr>
-              <a:t>Step 2</a:t>
-            </a:r>
-          </a:p>
-          <a:p>
-            <a:pPr>
-              <a:spcAft>
-                <a:spcPts val="600"/>
-              </a:spcAft>
-            </a:pPr>
-            <a:r>
-              <a:rPr lang="en-US" sz="1400" dirty="0">
-                <a:solidFill>
-                  <a:schemeClr val="accent4"/>
-                </a:solidFill>
-                <a:latin typeface="IBM Plex Sans ExtLt" panose="020B0303050203000203" pitchFamily="34" charset="0"/>
-              </a:rPr>
-              <a:t>Step 3</a:t>
-            </a:r>
-          </a:p>
-        </p:txBody>
-      </p:sp>
-      <p:sp>
-        <p:nvSpPr>
-          <p:cNvPr id="10" name="Triangle 9">
-            <a:extLst>
-              <a:ext uri="{FF2B5EF4-FFF2-40B4-BE49-F238E27FC236}">
-                <a16:creationId xmlns:a16="http://schemas.microsoft.com/office/drawing/2014/main" id="{7577DF1C-BFCE-87EB-8822-1658FE3A867F}"/>
-              </a:ext>
-            </a:extLst>
-          </p:cNvPr>
-          <p:cNvSpPr/>
-          <p:nvPr/>
-        </p:nvSpPr>
-        <p:spPr>
-          <a:xfrm rot="10800000">
-            <a:off x="908584" y="2695680"/>
-            <a:ext cx="171069" cy="139054"/>
-          </a:xfrm>
-          <a:prstGeom prst="triangle">
-            <a:avLst/>
-          </a:prstGeom>
-          <a:solidFill>
-            <a:schemeClr val="accent4">
-              <a:lumMod val="20000"/>
-              <a:lumOff val="80000"/>
-            </a:schemeClr>
-          </a:solidFill>
-          <a:ln>
-            <a:solidFill>
-              <a:schemeClr val="accent4"/>
-            </a:solidFill>
-          </a:ln>
-        </p:spPr>
-        <p:style>
-          <a:lnRef idx="2">
-            <a:schemeClr val="accent1">
-              <a:shade val="15000"/>
-            </a:schemeClr>
-          </a:lnRef>
-          <a:fillRef idx="1">
-            <a:schemeClr val="accent1"/>
-          </a:fillRef>
-          <a:effectRef idx="0">
-            <a:schemeClr val="accent1"/>
-          </a:effectRef>
-          <a:fontRef idx="minor">
-            <a:schemeClr val="lt1"/>
-          </a:fontRef>
-        </p:style>
-        <p:txBody>
-          <a:bodyPr rtlCol="0" anchor="ctr"/>
-          <a:lstStyle/>
-          <a:p>
-            <a:pPr algn="ctr"/>
-            <a:endParaRPr lang="en-US"/>
-          </a:p>
-        </p:txBody>
-      </p:sp>
-      <p:sp>
-        <p:nvSpPr>
-          <p:cNvPr id="11" name="Triangle 10">
-            <a:extLst>
-              <a:ext uri="{FF2B5EF4-FFF2-40B4-BE49-F238E27FC236}">
-                <a16:creationId xmlns:a16="http://schemas.microsoft.com/office/drawing/2014/main" id="{CBA69871-7994-9D13-A6D5-F0F5EF787368}"/>
-              </a:ext>
-            </a:extLst>
-          </p:cNvPr>
-          <p:cNvSpPr/>
-          <p:nvPr/>
-        </p:nvSpPr>
-        <p:spPr>
-          <a:xfrm rot="10800000">
-            <a:off x="917763" y="3002318"/>
-            <a:ext cx="171069" cy="139054"/>
-          </a:xfrm>
-          <a:prstGeom prst="triangle">
-            <a:avLst/>
-          </a:prstGeom>
-          <a:solidFill>
-            <a:schemeClr val="accent4">
-              <a:lumMod val="20000"/>
-              <a:lumOff val="80000"/>
-            </a:schemeClr>
-          </a:solidFill>
-          <a:ln>
-            <a:solidFill>
-              <a:schemeClr val="accent4"/>
-            </a:solidFill>
-          </a:ln>
-        </p:spPr>
-        <p:style>
-          <a:lnRef idx="2">
-            <a:schemeClr val="accent1">
-              <a:shade val="15000"/>
-            </a:schemeClr>
-          </a:lnRef>
-          <a:fillRef idx="1">
-            <a:schemeClr val="accent1"/>
-          </a:fillRef>
-          <a:effectRef idx="0">
-            <a:schemeClr val="accent1"/>
-          </a:effectRef>
-          <a:fontRef idx="minor">
-            <a:schemeClr val="lt1"/>
-          </a:fontRef>
-        </p:style>
-        <p:txBody>
-          <a:bodyPr rtlCol="0" anchor="ctr"/>
-          <a:lstStyle/>
-          <a:p>
-            <a:pPr algn="ctr"/>
-            <a:endParaRPr lang="en-US"/>
-          </a:p>
-        </p:txBody>
-      </p:sp>
-      <p:sp>
-        <p:nvSpPr>
-          <p:cNvPr id="17" name="Triangle 16">
-            <a:extLst>
-              <a:ext uri="{FF2B5EF4-FFF2-40B4-BE49-F238E27FC236}">
-                <a16:creationId xmlns:a16="http://schemas.microsoft.com/office/drawing/2014/main" id="{FB249469-8CFF-9510-F29D-9D36A8F65ED8}"/>
-              </a:ext>
-            </a:extLst>
-          </p:cNvPr>
-          <p:cNvSpPr/>
-          <p:nvPr/>
-        </p:nvSpPr>
-        <p:spPr>
-          <a:xfrm rot="10800000">
-            <a:off x="915925" y="3297939"/>
-            <a:ext cx="171069" cy="139054"/>
-          </a:xfrm>
-          <a:prstGeom prst="triangle">
-            <a:avLst/>
-          </a:prstGeom>
-          <a:solidFill>
-            <a:schemeClr val="accent4">
-              <a:lumMod val="20000"/>
-              <a:lumOff val="80000"/>
-            </a:schemeClr>
-          </a:solidFill>
-          <a:ln>
-            <a:solidFill>
-              <a:schemeClr val="accent4"/>
-            </a:solidFill>
-          </a:ln>
-        </p:spPr>
-        <p:style>
-          <a:lnRef idx="2">
-            <a:schemeClr val="accent1">
-              <a:shade val="15000"/>
-            </a:schemeClr>
-          </a:lnRef>
-          <a:fillRef idx="1">
-            <a:schemeClr val="accent1"/>
-          </a:fillRef>
-          <a:effectRef idx="0">
-            <a:schemeClr val="accent1"/>
-          </a:effectRef>
-          <a:fontRef idx="minor">
-            <a:schemeClr val="lt1"/>
-          </a:fontRef>
-        </p:style>
-        <p:txBody>
-          <a:bodyPr rtlCol="0" anchor="ctr"/>
-          <a:lstStyle/>
-          <a:p>
-            <a:pPr algn="ctr"/>
-            <a:endParaRPr lang="en-US"/>
-          </a:p>
-        </p:txBody>
-      </p:sp>
-      <p:sp>
-        <p:nvSpPr>
-          <p:cNvPr id="21" name="TextBox 20">
-            <a:extLst>
-              <a:ext uri="{FF2B5EF4-FFF2-40B4-BE49-F238E27FC236}">
-                <a16:creationId xmlns:a16="http://schemas.microsoft.com/office/drawing/2014/main" id="{3AB2F13F-0AD1-A74F-D5FC-ED7517B566C4}"/>
-              </a:ext>
-            </a:extLst>
-          </p:cNvPr>
-          <p:cNvSpPr txBox="1"/>
-          <p:nvPr/>
-        </p:nvSpPr>
-        <p:spPr>
-          <a:xfrm>
-            <a:off x="1636005" y="5310809"/>
-            <a:ext cx="4120309" cy="646331"/>
-          </a:xfrm>
-          <a:prstGeom prst="rect">
-            <a:avLst/>
-          </a:prstGeom>
-          <a:noFill/>
-        </p:spPr>
-        <p:txBody>
-          <a:bodyPr wrap="square" rtlCol="0">
-            <a:spAutoFit/>
-          </a:bodyPr>
-          <a:lstStyle/>
-          <a:p>
-            <a:r>
-              <a:rPr lang="en-US" dirty="0"/>
-              <a:t>Please wait while the agent processes its response…</a:t>
-            </a:r>
-          </a:p>
-        </p:txBody>
-      </p:sp>
-      <p:pic>
-        <p:nvPicPr>
-          <p:cNvPr id="25" name="Picture 2" descr="Please Wait Notepad Icons - Free SVG &amp; PNG Please Wait ...">
-            <a:extLst>
-              <a:ext uri="{FF2B5EF4-FFF2-40B4-BE49-F238E27FC236}">
-                <a16:creationId xmlns:a16="http://schemas.microsoft.com/office/drawing/2014/main" id="{41DD67B2-06BE-8845-FFFC-2066F45E657E}"/>
-              </a:ext>
-            </a:extLst>
-          </p:cNvPr>
-          <p:cNvPicPr>
-            <a:picLocks noChangeAspect="1" noChangeArrowheads="1"/>
-          </p:cNvPicPr>
-          <p:nvPr/>
-        </p:nvPicPr>
-        <p:blipFill>
-          <a:blip r:embed="rId3">
-            <a:extLst>
-              <a:ext uri="{28A0092B-C50C-407E-A947-70E740481C1C}">
-                <a14:useLocalDpi xmlns:a14="http://schemas.microsoft.com/office/drawing/2010/main" val="0"/>
-              </a:ext>
-            </a:extLst>
-          </a:blip>
-          <a:srcRect/>
-          <a:stretch>
-            <a:fillRect/>
-          </a:stretch>
-        </p:blipFill>
-        <p:spPr bwMode="auto">
-          <a:xfrm>
-            <a:off x="705079" y="5099657"/>
-            <a:ext cx="1068637" cy="1068637"/>
-          </a:xfrm>
-          <a:prstGeom prst="rect">
-            <a:avLst/>
-          </a:prstGeom>
-          <a:noFill/>
-          <a:extLst>
-            <a:ext uri="{909E8E84-426E-40DD-AFC4-6F175D3DCCD1}">
-              <a14:hiddenFill xmlns:a14="http://schemas.microsoft.com/office/drawing/2010/main">
-                <a:solidFill>
-                  <a:srgbClr val="FFFFFF"/>
-                </a:solidFill>
-              </a14:hiddenFill>
-            </a:ext>
-          </a:extLst>
-        </p:spPr>
-      </p:pic>
-      <p:sp>
-        <p:nvSpPr>
-          <p:cNvPr id="26" name="TextBox 25">
-            <a:extLst>
-              <a:ext uri="{FF2B5EF4-FFF2-40B4-BE49-F238E27FC236}">
-                <a16:creationId xmlns:a16="http://schemas.microsoft.com/office/drawing/2014/main" id="{D7682D0D-E7D8-C1EA-C45B-23E3673406B7}"/>
-              </a:ext>
-            </a:extLst>
-          </p:cNvPr>
-          <p:cNvSpPr txBox="1"/>
-          <p:nvPr/>
-        </p:nvSpPr>
-        <p:spPr>
-          <a:xfrm>
-            <a:off x="732622" y="4920536"/>
-            <a:ext cx="3525324" cy="307777"/>
-          </a:xfrm>
-          <a:prstGeom prst="rect">
-            <a:avLst/>
-          </a:prstGeom>
-          <a:noFill/>
-        </p:spPr>
-        <p:txBody>
-          <a:bodyPr wrap="none" rtlCol="0">
-            <a:spAutoFit/>
-          </a:bodyPr>
-          <a:lstStyle/>
-          <a:p>
-            <a:r>
-              <a:rPr lang="en-US" sz="1400" dirty="0">
-                <a:latin typeface="IBM Plex Sans ExtLt" panose="020B0303050203000203" pitchFamily="34" charset="0"/>
-              </a:rPr>
-              <a:t>agent @ 1:31 pm</a:t>
-            </a:r>
-            <a:r>
-              <a:rPr lang="en-US" sz="1400" dirty="0">
-                <a:solidFill>
-                  <a:schemeClr val="accent4"/>
-                </a:solidFill>
-                <a:latin typeface="IBM Plex Sans ExtLt" panose="020B0303050203000203" pitchFamily="34" charset="0"/>
-              </a:rPr>
-              <a:t> | Show agent’s reasoning</a:t>
-            </a:r>
-          </a:p>
-        </p:txBody>
-      </p:sp>
-      <p:sp>
-        <p:nvSpPr>
-          <p:cNvPr id="27" name="Triangle 26">
-            <a:extLst>
-              <a:ext uri="{FF2B5EF4-FFF2-40B4-BE49-F238E27FC236}">
-                <a16:creationId xmlns:a16="http://schemas.microsoft.com/office/drawing/2014/main" id="{7E2DBCA6-9C95-C39C-75FC-2145E80C7DF6}"/>
-              </a:ext>
-            </a:extLst>
-          </p:cNvPr>
-          <p:cNvSpPr/>
-          <p:nvPr/>
-        </p:nvSpPr>
-        <p:spPr>
-          <a:xfrm rot="10800000">
-            <a:off x="4170217" y="5013356"/>
-            <a:ext cx="171069" cy="139054"/>
-          </a:xfrm>
-          <a:prstGeom prst="triangle">
-            <a:avLst/>
-          </a:prstGeom>
-          <a:solidFill>
-            <a:schemeClr val="accent4">
-              <a:lumMod val="20000"/>
-              <a:lumOff val="80000"/>
-            </a:schemeClr>
-          </a:solidFill>
-        </p:spPr>
-        <p:style>
-          <a:lnRef idx="2">
-            <a:schemeClr val="accent1">
-              <a:shade val="15000"/>
-            </a:schemeClr>
-          </a:lnRef>
-          <a:fillRef idx="1">
-            <a:schemeClr val="accent1"/>
-          </a:fillRef>
-          <a:effectRef idx="0">
-            <a:schemeClr val="accent1"/>
-          </a:effectRef>
-          <a:fontRef idx="minor">
-            <a:schemeClr val="lt1"/>
-          </a:fontRef>
-        </p:style>
-        <p:txBody>
-          <a:bodyPr rtlCol="0" anchor="ctr"/>
-          <a:lstStyle/>
-          <a:p>
-            <a:pPr algn="ctr"/>
-            <a:endParaRPr lang="en-US"/>
           </a:p>
         </p:txBody>
       </p:sp>

</xml_diff>